<commit_message>
implement feedback on final presentation (#28)
* feedback implemented

* apply feedback
</commit_message>
<xml_diff>
--- a/project_documents/DS785_Final_Presentation.pptx
+++ b/project_documents/DS785_Final_Presentation.pptx
@@ -5266,7 +5266,7 @@
           </a:pPr>
           <a:r>
             <a:rPr lang="en-US" b="1" dirty="0"/>
-            <a:t>Domain-Specific Data Wins</a:t>
+            <a:t>Domain-Specific Language Wins</a:t>
           </a:r>
         </a:p>
         <a:p>
@@ -5275,7 +5275,44 @@
           </a:pPr>
           <a:r>
             <a:rPr lang="en-US" dirty="0"/>
-            <a:t>Project-specific labeled data outperformed general-purpose sentiment analysis models.</a:t>
+            <a:t>Project-specific labeled data outperformed general-purpose sentiment models. </a:t>
+          </a:r>
+        </a:p>
+        <a:p>
+          <a:pPr>
+            <a:buNone/>
+          </a:pPr>
+          <a:r>
+            <a:rPr lang="en-US" i="1" dirty="0"/>
+            <a:t>Examples: plush</a:t>
+          </a:r>
+          <a:r>
+            <a:rPr lang="en-US" dirty="0"/>
+            <a:t>, </a:t>
+          </a:r>
+          <a:r>
+            <a:rPr lang="en-US" i="1" dirty="0"/>
+            <a:t>harsh</a:t>
+          </a:r>
+          <a:r>
+            <a:rPr lang="en-US" dirty="0"/>
+            <a:t>, </a:t>
+          </a:r>
+          <a:r>
+            <a:rPr lang="en-US" i="1" dirty="0"/>
+            <a:t>progressive</a:t>
+          </a:r>
+          <a:r>
+            <a:rPr lang="en-US" dirty="0"/>
+            <a:t>, and </a:t>
+          </a:r>
+          <a:r>
+            <a:rPr lang="en-US" i="1" dirty="0"/>
+            <a:t>bottom-out</a:t>
+          </a:r>
+          <a:r>
+            <a:rPr lang="en-US" dirty="0"/>
+            <a:t>.</a:t>
           </a:r>
         </a:p>
       </dgm:t>
@@ -5599,10 +5636,9 @@
         <a:lstStyle/>
         <a:p>
           <a:r>
-            <a:rPr lang="en-US"/>
-            <a:t>Product improvement </a:t>
+            <a:rPr lang="en-US" dirty="0"/>
+            <a:t>Identify recurring complaints</a:t>
           </a:r>
-          <a:endParaRPr lang="en-US" dirty="0"/>
         </a:p>
       </dgm:t>
     </dgm:pt>
@@ -6001,8 +6037,8 @@
             <a:buChar char="•"/>
           </a:pPr>
           <a:r>
-            <a:rPr lang="en-US"/>
-            <a:t>Design priorities </a:t>
+            <a:rPr lang="en-US" dirty="0"/>
+            <a:t>Prioritize engineering improvements</a:t>
           </a:r>
         </a:p>
       </dgm:t>
@@ -6042,7 +6078,7 @@
           </a:pPr>
           <a:r>
             <a:rPr lang="en-US" dirty="0"/>
-            <a:t>Market trends</a:t>
+            <a:t>Monitor market trends</a:t>
           </a:r>
         </a:p>
       </dgm:t>
@@ -8613,8 +8649,8 @@
       </dsp:nvSpPr>
       <dsp:spPr>
         <a:xfrm>
-          <a:off x="0" y="49661"/>
-          <a:ext cx="8987404" cy="858414"/>
+          <a:off x="0" y="6450"/>
+          <a:ext cx="8987404" cy="882180"/>
         </a:xfrm>
         <a:prstGeom prst="roundRect">
           <a:avLst/>
@@ -8670,12 +8706,12 @@
         </a:fontRef>
       </dsp:style>
       <dsp:txBody>
-        <a:bodyPr spcFirstLastPara="0" vert="horz" wrap="square" lIns="53340" tIns="53340" rIns="53340" bIns="53340" numCol="1" spcCol="1270" anchor="ctr" anchorCtr="0">
+        <a:bodyPr spcFirstLastPara="0" vert="horz" wrap="square" lIns="49530" tIns="49530" rIns="49530" bIns="49530" numCol="1" spcCol="1270" anchor="ctr" anchorCtr="0">
           <a:noAutofit/>
         </a:bodyPr>
         <a:lstStyle/>
         <a:p>
-          <a:pPr marL="0" lvl="0" indent="0" algn="l" defTabSz="622300">
+          <a:pPr marL="0" lvl="0" indent="0" algn="l" defTabSz="577850">
             <a:lnSpc>
               <a:spcPct val="90000"/>
             </a:lnSpc>
@@ -8688,12 +8724,12 @@
             <a:buNone/>
           </a:pPr>
           <a:r>
-            <a:rPr lang="en-US" sz="1400" b="1" kern="1200" dirty="0"/>
-            <a:t>Domain-Specific Data Wins</a:t>
+            <a:rPr lang="en-US" sz="1300" b="1" kern="1200" dirty="0"/>
+            <a:t>Domain-Specific Language Wins</a:t>
           </a:r>
         </a:p>
         <a:p>
-          <a:pPr marL="0" lvl="0" indent="0" algn="l" defTabSz="622300">
+          <a:pPr marL="0" lvl="0" indent="0" algn="l" defTabSz="577850">
             <a:lnSpc>
               <a:spcPct val="90000"/>
             </a:lnSpc>
@@ -8706,14 +8742,60 @@
             <a:buNone/>
           </a:pPr>
           <a:r>
-            <a:rPr lang="en-US" sz="1400" kern="1200" dirty="0"/>
-            <a:t>Project-specific labeled data outperformed general-purpose sentiment analysis models.</a:t>
+            <a:rPr lang="en-US" sz="1300" kern="1200" dirty="0"/>
+            <a:t>Project-specific labeled data outperformed general-purpose sentiment models. </a:t>
+          </a:r>
+        </a:p>
+        <a:p>
+          <a:pPr marL="0" lvl="0" indent="0" algn="l" defTabSz="577850">
+            <a:lnSpc>
+              <a:spcPct val="90000"/>
+            </a:lnSpc>
+            <a:spcBef>
+              <a:spcPct val="0"/>
+            </a:spcBef>
+            <a:spcAft>
+              <a:spcPct val="35000"/>
+            </a:spcAft>
+            <a:buNone/>
+          </a:pPr>
+          <a:r>
+            <a:rPr lang="en-US" sz="1300" i="1" kern="1200" dirty="0"/>
+            <a:t>Examples: plush</a:t>
+          </a:r>
+          <a:r>
+            <a:rPr lang="en-US" sz="1300" kern="1200" dirty="0"/>
+            <a:t>, </a:t>
+          </a:r>
+          <a:r>
+            <a:rPr lang="en-US" sz="1300" i="1" kern="1200" dirty="0"/>
+            <a:t>harsh</a:t>
+          </a:r>
+          <a:r>
+            <a:rPr lang="en-US" sz="1300" kern="1200" dirty="0"/>
+            <a:t>, </a:t>
+          </a:r>
+          <a:r>
+            <a:rPr lang="en-US" sz="1300" i="1" kern="1200" dirty="0"/>
+            <a:t>progressive</a:t>
+          </a:r>
+          <a:r>
+            <a:rPr lang="en-US" sz="1300" kern="1200" dirty="0"/>
+            <a:t>, and </a:t>
+          </a:r>
+          <a:r>
+            <a:rPr lang="en-US" sz="1300" i="1" kern="1200" dirty="0"/>
+            <a:t>bottom-out</a:t>
+          </a:r>
+          <a:r>
+            <a:rPr lang="en-US" sz="1300" kern="1200" dirty="0"/>
+            <a:t>.</a:t>
           </a:r>
         </a:p>
       </dsp:txBody>
       <dsp:txXfrm>
-        <a:off x="41904" y="91565"/>
-        <a:ext cx="8903596" cy="774606"/>
+        <a:off x="43064" y="49514"/>
+        <a:ext cx="8901276" cy="796052"/>
       </dsp:txXfrm>
     </dsp:sp>
     <dsp:sp modelId="{1AC44C57-C3D8-6947-9E04-8C93241412E5}">
@@ -8723,8 +8805,8 @@
       </dsp:nvSpPr>
       <dsp:spPr>
         <a:xfrm>
-          <a:off x="0" y="948396"/>
-          <a:ext cx="8987404" cy="858414"/>
+          <a:off x="0" y="926070"/>
+          <a:ext cx="8987404" cy="882180"/>
         </a:xfrm>
         <a:prstGeom prst="roundRect">
           <a:avLst/>
@@ -8780,12 +8862,12 @@
         </a:fontRef>
       </dsp:style>
       <dsp:txBody>
-        <a:bodyPr spcFirstLastPara="0" vert="horz" wrap="square" lIns="53340" tIns="53340" rIns="53340" bIns="53340" numCol="1" spcCol="1270" anchor="ctr" anchorCtr="0">
+        <a:bodyPr spcFirstLastPara="0" vert="horz" wrap="square" lIns="49530" tIns="49530" rIns="49530" bIns="49530" numCol="1" spcCol="1270" anchor="ctr" anchorCtr="0">
           <a:noAutofit/>
         </a:bodyPr>
         <a:lstStyle/>
         <a:p>
-          <a:pPr marL="0" lvl="0" indent="0" algn="l" defTabSz="622300">
+          <a:pPr marL="0" lvl="0" indent="0" algn="l" defTabSz="577850">
             <a:lnSpc>
               <a:spcPct val="90000"/>
             </a:lnSpc>
@@ -8798,12 +8880,12 @@
             <a:buNone/>
           </a:pPr>
           <a:r>
-            <a:rPr lang="en-US" sz="1400" b="1" kern="1200" dirty="0"/>
+            <a:rPr lang="en-US" sz="1300" b="1" kern="1200" dirty="0"/>
             <a:t>Multiple Metrics Matter</a:t>
           </a:r>
         </a:p>
         <a:p>
-          <a:pPr marL="0" lvl="0" indent="0" algn="l" defTabSz="622300">
+          <a:pPr marL="0" lvl="0" indent="0" algn="l" defTabSz="577850">
             <a:lnSpc>
               <a:spcPct val="90000"/>
             </a:lnSpc>
@@ -8816,14 +8898,14 @@
             <a:buNone/>
           </a:pPr>
           <a:r>
-            <a:rPr lang="en-US" sz="1400" kern="1200" dirty="0"/>
+            <a:rPr lang="en-US" sz="1300" kern="1200" dirty="0"/>
             <a:t>Accuracy alone favored VADER, while Balanced Accuracy, Macro F1, and ROC AUC identified the strongest overall-performing model.</a:t>
           </a:r>
         </a:p>
       </dsp:txBody>
       <dsp:txXfrm>
-        <a:off x="41904" y="990300"/>
-        <a:ext cx="8903596" cy="774606"/>
+        <a:off x="43064" y="969134"/>
+        <a:ext cx="8901276" cy="796052"/>
       </dsp:txXfrm>
     </dsp:sp>
     <dsp:sp modelId="{C9D919A2-B9B0-C945-82DE-C10707AF9C4E}">
@@ -8833,8 +8915,8 @@
       </dsp:nvSpPr>
       <dsp:spPr>
         <a:xfrm>
-          <a:off x="0" y="1847130"/>
-          <a:ext cx="8987404" cy="858414"/>
+          <a:off x="0" y="1845690"/>
+          <a:ext cx="8987404" cy="882180"/>
         </a:xfrm>
         <a:prstGeom prst="roundRect">
           <a:avLst/>
@@ -8890,12 +8972,12 @@
         </a:fontRef>
       </dsp:style>
       <dsp:txBody>
-        <a:bodyPr spcFirstLastPara="0" vert="horz" wrap="square" lIns="53340" tIns="53340" rIns="53340" bIns="53340" numCol="1" spcCol="1270" anchor="ctr" anchorCtr="0">
+        <a:bodyPr spcFirstLastPara="0" vert="horz" wrap="square" lIns="49530" tIns="49530" rIns="49530" bIns="49530" numCol="1" spcCol="1270" anchor="ctr" anchorCtr="0">
           <a:noAutofit/>
         </a:bodyPr>
         <a:lstStyle/>
         <a:p>
-          <a:pPr marL="0" lvl="0" indent="0" algn="l" defTabSz="622300">
+          <a:pPr marL="0" lvl="0" indent="0" algn="l" defTabSz="577850">
             <a:lnSpc>
               <a:spcPct val="90000"/>
             </a:lnSpc>
@@ -8908,12 +8990,12 @@
             <a:buNone/>
           </a:pPr>
           <a:r>
-            <a:rPr lang="en-US" sz="1400" b="1" kern="1200" dirty="0"/>
+            <a:rPr lang="en-US" sz="1300" b="1" kern="1200" dirty="0"/>
             <a:t>Model Complexity Isn't Everything</a:t>
           </a:r>
         </a:p>
         <a:p>
-          <a:pPr marL="0" lvl="0" indent="0" algn="l" defTabSz="622300">
+          <a:pPr marL="0" lvl="0" indent="0" algn="l" defTabSz="577850">
             <a:lnSpc>
               <a:spcPct val="90000"/>
             </a:lnSpc>
@@ -8926,22 +9008,22 @@
             <a:buNone/>
           </a:pPr>
           <a:r>
-            <a:rPr lang="en-US" sz="1400" kern="1200" dirty="0"/>
+            <a:rPr lang="en-US" sz="1300" kern="1200" dirty="0"/>
             <a:t>The pretrained </a:t>
           </a:r>
           <a:r>
-            <a:rPr lang="en-US" sz="1400" kern="1200" dirty="0" err="1"/>
+            <a:rPr lang="en-US" sz="1300" kern="1200" dirty="0" err="1"/>
             <a:t>RoBERTa</a:t>
           </a:r>
           <a:r>
-            <a:rPr lang="en-US" sz="1400" kern="1200" dirty="0"/>
+            <a:rPr lang="en-US" sz="1300" kern="1200" dirty="0"/>
             <a:t> transformer underperformed despite its advanced architecture.</a:t>
           </a:r>
         </a:p>
       </dsp:txBody>
       <dsp:txXfrm>
-        <a:off x="41904" y="1889034"/>
-        <a:ext cx="8903596" cy="774606"/>
+        <a:off x="43064" y="1888754"/>
+        <a:ext cx="8901276" cy="796052"/>
       </dsp:txXfrm>
     </dsp:sp>
     <dsp:sp modelId="{8F5C5369-D061-0841-A819-D9215E6EF95D}">
@@ -8951,8 +9033,8 @@
       </dsp:nvSpPr>
       <dsp:spPr>
         <a:xfrm>
-          <a:off x="0" y="2745864"/>
-          <a:ext cx="8987404" cy="858414"/>
+          <a:off x="0" y="2765310"/>
+          <a:ext cx="8987404" cy="882180"/>
         </a:xfrm>
         <a:prstGeom prst="roundRect">
           <a:avLst/>
@@ -9008,12 +9090,12 @@
         </a:fontRef>
       </dsp:style>
       <dsp:txBody>
-        <a:bodyPr spcFirstLastPara="0" vert="horz" wrap="square" lIns="53340" tIns="53340" rIns="53340" bIns="53340" numCol="1" spcCol="1270" anchor="ctr" anchorCtr="0">
+        <a:bodyPr spcFirstLastPara="0" vert="horz" wrap="square" lIns="49530" tIns="49530" rIns="49530" bIns="49530" numCol="1" spcCol="1270" anchor="ctr" anchorCtr="0">
           <a:noAutofit/>
         </a:bodyPr>
         <a:lstStyle/>
         <a:p>
-          <a:pPr marL="0" lvl="0" indent="0" algn="l" defTabSz="622300">
+          <a:pPr marL="0" lvl="0" indent="0" algn="l" defTabSz="577850">
             <a:lnSpc>
               <a:spcPct val="90000"/>
             </a:lnSpc>
@@ -9026,13 +9108,13 @@
             <a:buNone/>
           </a:pPr>
           <a:r>
-            <a:rPr lang="en-US" sz="1400" b="1" kern="1200" dirty="0"/>
+            <a:rPr lang="en-US" sz="1300" b="1" kern="1200" dirty="0"/>
             <a:t>NLP Can Scale Review Analysis</a:t>
           </a:r>
-          <a:endParaRPr lang="en-US" sz="1400" kern="1200" dirty="0"/>
+          <a:endParaRPr lang="en-US" sz="1300" kern="1200" dirty="0"/>
         </a:p>
         <a:p>
-          <a:pPr marL="0" lvl="0" indent="0" algn="l" defTabSz="622300">
+          <a:pPr marL="0" lvl="0" indent="0" algn="l" defTabSz="577850">
             <a:lnSpc>
               <a:spcPct val="90000"/>
             </a:lnSpc>
@@ -9045,14 +9127,14 @@
             <a:buNone/>
           </a:pPr>
           <a:r>
-            <a:rPr lang="en-US" sz="1400" kern="1200" dirty="0"/>
+            <a:rPr lang="en-US" sz="1300" kern="1200" dirty="0"/>
             <a:t>Automated sentiment analysis enables efficient comparison of products, brands, and review trends.</a:t>
           </a:r>
         </a:p>
       </dsp:txBody>
       <dsp:txXfrm>
-        <a:off x="41904" y="2787768"/>
-        <a:ext cx="8903596" cy="774606"/>
+        <a:off x="43064" y="2808374"/>
+        <a:ext cx="8901276" cy="796052"/>
       </dsp:txXfrm>
     </dsp:sp>
   </dsp:spTree>
@@ -9176,12 +9258,12 @@
         </a:fontRef>
       </dsp:style>
       <dsp:txBody>
-        <a:bodyPr spcFirstLastPara="0" vert="horz" wrap="square" lIns="128016" tIns="278850" rIns="128016" bIns="128016" numCol="1" spcCol="1270" anchor="t" anchorCtr="0">
+        <a:bodyPr spcFirstLastPara="0" vert="horz" wrap="square" lIns="120904" tIns="278850" rIns="120904" bIns="120904" numCol="1" spcCol="1270" anchor="t" anchorCtr="0">
           <a:noAutofit/>
         </a:bodyPr>
         <a:lstStyle/>
         <a:p>
-          <a:pPr marL="114300" lvl="1" indent="-114300" algn="l" defTabSz="622300">
+          <a:pPr marL="114300" lvl="1" indent="-114300" algn="l" defTabSz="577850">
             <a:lnSpc>
               <a:spcPct val="90000"/>
             </a:lnSpc>
@@ -9194,13 +9276,12 @@
             <a:buChar char="•"/>
           </a:pPr>
           <a:r>
-            <a:rPr lang="en-US" sz="1400" kern="1200"/>
-            <a:t>Product improvement </a:t>
+            <a:rPr lang="en-US" sz="1300" kern="1200" dirty="0"/>
+            <a:t>Identify recurring complaints</a:t>
           </a:r>
-          <a:endParaRPr lang="en-US" sz="1400" kern="1200" dirty="0"/>
         </a:p>
         <a:p>
-          <a:pPr marL="114300" lvl="1" indent="-114300" algn="l" defTabSz="622300">
+          <a:pPr marL="114300" lvl="1" indent="-114300" algn="l" defTabSz="577850">
             <a:lnSpc>
               <a:spcPct val="90000"/>
             </a:lnSpc>
@@ -9214,12 +9295,12 @@
             <a:buChar char="•"/>
           </a:pPr>
           <a:r>
-            <a:rPr lang="en-US" sz="1400" kern="1200"/>
-            <a:t>Design priorities </a:t>
+            <a:rPr lang="en-US" sz="1300" kern="1200" dirty="0"/>
+            <a:t>Prioritize engineering improvements</a:t>
           </a:r>
         </a:p>
         <a:p>
-          <a:pPr marL="114300" lvl="1" indent="-114300" algn="l" defTabSz="622300">
+          <a:pPr marL="114300" lvl="1" indent="-114300" algn="l" defTabSz="577850">
             <a:lnSpc>
               <a:spcPct val="90000"/>
             </a:lnSpc>
@@ -9233,8 +9314,8 @@
             <a:buChar char="•"/>
           </a:pPr>
           <a:r>
-            <a:rPr lang="en-US" sz="1400" kern="1200" dirty="0"/>
-            <a:t>Market trends</a:t>
+            <a:rPr lang="en-US" sz="1300" kern="1200" dirty="0"/>
+            <a:t>Monitor market trends</a:t>
           </a:r>
         </a:p>
       </dsp:txBody>
@@ -9404,12 +9485,12 @@
         </a:fontRef>
       </dsp:style>
       <dsp:txBody>
-        <a:bodyPr spcFirstLastPara="0" vert="horz" wrap="square" lIns="128016" tIns="278850" rIns="128016" bIns="128016" numCol="1" spcCol="1270" anchor="t" anchorCtr="0">
+        <a:bodyPr spcFirstLastPara="0" vert="horz" wrap="square" lIns="120904" tIns="278850" rIns="120904" bIns="120904" numCol="1" spcCol="1270" anchor="t" anchorCtr="0">
           <a:noAutofit/>
         </a:bodyPr>
         <a:lstStyle/>
         <a:p>
-          <a:pPr marL="114300" lvl="1" indent="-114300" algn="l" defTabSz="622300">
+          <a:pPr marL="114300" lvl="1" indent="-114300" algn="l" defTabSz="577850">
             <a:lnSpc>
               <a:spcPct val="90000"/>
             </a:lnSpc>
@@ -9422,12 +9503,12 @@
             <a:buChar char="•"/>
           </a:pPr>
           <a:r>
-            <a:rPr lang="en-US" sz="1400" kern="1200" dirty="0"/>
+            <a:rPr lang="en-US" sz="1300" kern="1200" dirty="0"/>
             <a:t>Compare brands</a:t>
           </a:r>
         </a:p>
         <a:p>
-          <a:pPr marL="114300" lvl="1" indent="-114300" algn="l" defTabSz="622300">
+          <a:pPr marL="114300" lvl="1" indent="-114300" algn="l" defTabSz="577850">
             <a:lnSpc>
               <a:spcPct val="90000"/>
             </a:lnSpc>
@@ -9440,12 +9521,12 @@
             <a:buChar char="•"/>
           </a:pPr>
           <a:r>
-            <a:rPr lang="en-US" sz="1400" kern="1200" dirty="0"/>
+            <a:rPr lang="en-US" sz="1300" kern="1200" dirty="0"/>
             <a:t>Buying decisions</a:t>
           </a:r>
         </a:p>
         <a:p>
-          <a:pPr marL="114300" lvl="1" indent="-114300" algn="l" defTabSz="622300">
+          <a:pPr marL="114300" lvl="1" indent="-114300" algn="l" defTabSz="577850">
             <a:lnSpc>
               <a:spcPct val="90000"/>
             </a:lnSpc>
@@ -9458,7 +9539,7 @@
             <a:buChar char="•"/>
           </a:pPr>
           <a:r>
-            <a:rPr lang="en-US" sz="1400" kern="1200" dirty="0"/>
+            <a:rPr lang="en-US" sz="1300" kern="1200" dirty="0"/>
             <a:t>Product summaries</a:t>
           </a:r>
         </a:p>
@@ -9629,12 +9710,12 @@
         </a:fontRef>
       </dsp:style>
       <dsp:txBody>
-        <a:bodyPr spcFirstLastPara="0" vert="horz" wrap="square" lIns="128016" tIns="278850" rIns="128016" bIns="128016" numCol="1" spcCol="1270" anchor="t" anchorCtr="0">
+        <a:bodyPr spcFirstLastPara="0" vert="horz" wrap="square" lIns="120904" tIns="278850" rIns="120904" bIns="120904" numCol="1" spcCol="1270" anchor="t" anchorCtr="0">
           <a:noAutofit/>
         </a:bodyPr>
         <a:lstStyle/>
         <a:p>
-          <a:pPr marL="114300" lvl="1" indent="-114300" algn="l" defTabSz="622300">
+          <a:pPr marL="114300" lvl="1" indent="-114300" algn="l" defTabSz="577850">
             <a:lnSpc>
               <a:spcPct val="90000"/>
             </a:lnSpc>
@@ -9647,12 +9728,12 @@
             <a:buChar char="•"/>
           </a:pPr>
           <a:r>
-            <a:rPr lang="en-US" sz="1400" kern="1200" dirty="0"/>
+            <a:rPr lang="en-US" sz="1300" kern="1200" dirty="0"/>
             <a:t>Faster research</a:t>
           </a:r>
         </a:p>
         <a:p>
-          <a:pPr marL="114300" lvl="1" indent="-114300" algn="l" defTabSz="622300">
+          <a:pPr marL="114300" lvl="1" indent="-114300" algn="l" defTabSz="577850">
             <a:lnSpc>
               <a:spcPct val="90000"/>
             </a:lnSpc>
@@ -9665,12 +9746,12 @@
             <a:buChar char="•"/>
           </a:pPr>
           <a:r>
-            <a:rPr lang="en-US" sz="1400" kern="1200" dirty="0"/>
+            <a:rPr lang="en-US" sz="1300" kern="1200" dirty="0"/>
             <a:t>Compare products</a:t>
           </a:r>
         </a:p>
         <a:p>
-          <a:pPr marL="114300" lvl="1" indent="-114300" algn="l" defTabSz="622300">
+          <a:pPr marL="114300" lvl="1" indent="-114300" algn="l" defTabSz="577850">
             <a:lnSpc>
               <a:spcPct val="90000"/>
             </a:lnSpc>
@@ -9683,7 +9764,7 @@
             <a:buChar char="•"/>
           </a:pPr>
           <a:r>
-            <a:rPr lang="en-US" sz="1400" kern="1200" dirty="0"/>
+            <a:rPr lang="en-US" sz="1300" kern="1200" dirty="0"/>
             <a:t>Informed purchasing decisions</a:t>
           </a:r>
         </a:p>
@@ -9854,12 +9935,12 @@
         </a:fontRef>
       </dsp:style>
       <dsp:txBody>
-        <a:bodyPr spcFirstLastPara="0" vert="horz" wrap="square" lIns="128016" tIns="278850" rIns="128016" bIns="128016" numCol="1" spcCol="1270" anchor="t" anchorCtr="0">
+        <a:bodyPr spcFirstLastPara="0" vert="horz" wrap="square" lIns="120904" tIns="278850" rIns="120904" bIns="120904" numCol="1" spcCol="1270" anchor="t" anchorCtr="0">
           <a:noAutofit/>
         </a:bodyPr>
         <a:lstStyle/>
         <a:p>
-          <a:pPr marL="114300" lvl="1" indent="-114300" algn="l" defTabSz="622300">
+          <a:pPr marL="114300" lvl="1" indent="-114300" algn="l" defTabSz="577850">
             <a:lnSpc>
               <a:spcPct val="90000"/>
             </a:lnSpc>
@@ -9872,13 +9953,13 @@
             <a:buChar char="•"/>
           </a:pPr>
           <a:r>
-            <a:rPr lang="en-US" sz="1400" kern="1200"/>
+            <a:rPr lang="en-US" sz="1300" kern="1200"/>
             <a:t>NLP benchmarks </a:t>
           </a:r>
-          <a:endParaRPr lang="en-US" sz="1400" kern="1200" dirty="0"/>
+          <a:endParaRPr lang="en-US" sz="1300" kern="1200" dirty="0"/>
         </a:p>
         <a:p>
-          <a:pPr marL="114300" lvl="1" indent="-114300" algn="l" defTabSz="622300">
+          <a:pPr marL="114300" lvl="1" indent="-114300" algn="l" defTabSz="577850">
             <a:lnSpc>
               <a:spcPct val="90000"/>
             </a:lnSpc>
@@ -9892,12 +9973,12 @@
             <a:buChar char="•"/>
           </a:pPr>
           <a:r>
-            <a:rPr lang="en-US" sz="1400" kern="1200"/>
+            <a:rPr lang="en-US" sz="1300" kern="1200"/>
             <a:t>Domain adaptation </a:t>
           </a:r>
         </a:p>
         <a:p>
-          <a:pPr marL="114300" lvl="1" indent="-114300" algn="l" defTabSz="622300">
+          <a:pPr marL="114300" lvl="1" indent="-114300" algn="l" defTabSz="577850">
             <a:lnSpc>
               <a:spcPct val="90000"/>
             </a:lnSpc>
@@ -9911,7 +9992,7 @@
             <a:buChar char="•"/>
           </a:pPr>
           <a:r>
-            <a:rPr lang="en-US" sz="1400" kern="1200" dirty="0"/>
+            <a:rPr lang="en-US" sz="1300" kern="1200" dirty="0"/>
             <a:t>Future NLP research</a:t>
           </a:r>
         </a:p>
@@ -18697,7 +18778,7 @@
           <a:p>
             <a:fld id="{87F82D20-900E-6C40-A05F-D83DFCD9E8C9}" type="datetimeFigureOut">
               <a:rPr lang="en-US" smtClean="0"/>
-              <a:t>7/28/26</a:t>
+              <a:t>8/1/26</a:t>
             </a:fld>
             <a:endParaRPr lang="en-US"/>
           </a:p>
@@ -19105,7 +19186,39 @@
           <a:p>
             <a:r>
               <a:rPr lang="en-US" dirty="0"/>
-              <a:t>Before discussing the project results, I'd like to briefly revisit the problem this work was designed to solve. Professional mountain bike reviews provide detailed evaluations of product performance, durability, ride quality, and value, but their length makes them difficult to analyze across hundreds of articles. This project addressed that challenge by developing an end-to-end natural language processing pipeline capable of collecting review articles, processing their text, and classifying overall sentiment. The objectives were to compare multiple sentiment analysis approaches, evaluate their performance using standard machine learning metrics, and demonstrate how automated sentiment analysis can generate actionable business insights for manufacturers, retailers, and consumers.</a:t>
+              <a:t>Before discussing the project results, I'd like to briefly revisit the problem this work was designed to solve. Professional mountain bike reviews provide detailed evaluations of product performance, durability, ride quality, and value, but their length and highly specialized vocabulary make them difficult to analyze efficiently at scale. As the example review on the right illustrates, reviewers use terms such as </a:t>
+            </a:r>
+            <a:r>
+              <a:rPr lang="en-US" i="1" dirty="0"/>
+              <a:t>plush</a:t>
+            </a:r>
+            <a:r>
+              <a:rPr lang="en-US" dirty="0"/>
+              <a:t>, </a:t>
+            </a:r>
+            <a:r>
+              <a:rPr lang="en-US" i="1" dirty="0"/>
+              <a:t>harsh</a:t>
+            </a:r>
+            <a:r>
+              <a:rPr lang="en-US" dirty="0"/>
+              <a:t>, </a:t>
+            </a:r>
+            <a:r>
+              <a:rPr lang="en-US" i="1" dirty="0"/>
+              <a:t>square-edge</a:t>
+            </a:r>
+            <a:r>
+              <a:rPr lang="en-US" dirty="0"/>
+              <a:t>, and </a:t>
+            </a:r>
+            <a:r>
+              <a:rPr lang="en-US" i="1" dirty="0"/>
+              <a:t>composed</a:t>
+            </a:r>
+            <a:r>
+              <a:rPr lang="en-US" dirty="0"/>
+              <a:t> that have very specific meanings within the mountain biking community. General-purpose sentiment models are not necessarily trained to interpret this type of language, which makes domain-specific sentiment analysis especially challenging. This project addressed that challenge by developing an end-to-end natural language processing pipeline capable of collecting review articles, processing their text, and classifying overall sentiment. The objectives were to compare multiple sentiment analysis approaches, evaluate their performance using standard classification metrics, and demonstrate how automated sentiment analysis can generate actionable business insights for manufacturers, retailers, and consumers.</a:t>
             </a:r>
           </a:p>
         </p:txBody>
@@ -19502,7 +19615,7 @@
           <a:p>
             <a:r>
               <a:rPr lang="en-US" dirty="0"/>
-              <a:t>While this project focused on sentiment classification, its value extends beyond model performance. Manufacturers can use aggregated sentiment to identify recurring product strengths, design priorities, and emerging market trends. Retailers can compare brands and product categories to support merchandising and purchasing decisions. Consumers benefit from faster access to summarized review insights, allowing them to compare products more efficiently and make more informed purchasing decisions. Finally, the project provides a foundation for future research in domain-specific natural language processing and model development. Overall, automated sentiment analysis transforms large collections of unstructured review text into scalable, interpretable business intelligence that can support a wide range of decision-makers.</a:t>
+              <a:t>While this project focused on sentiment classification, its value extends well beyond model performance. For manufacturers, aggregated sentiment can reveal recurring themes across hundreds of professional reviews. For example, if hundreds of professional reviews consistently describe a bike's suspension as harsh or raise concerns about long-term durability, those patterns can help prioritize engineering improvements for future product releases. Retailers can compare sentiment across brands and product categories to support merchandising decisions and provide more meaningful product summaries to customers. Consumers benefit from faster access to concise review insights, allowing them to compare products more efficiently and make more informed purchasing decisions without reading dozens of full-length articles. Finally, this work provides a foundation for future research in domain-specific natural language processing, including larger datasets, specialized transformer models, and interactive business dashboards. Overall, automated sentiment analysis transforms large collections of unstructured review text into scalable, interpretable business intelligence that supports a wide range of decision-makers.</a:t>
             </a:r>
           </a:p>
         </p:txBody>
@@ -19929,7 +20042,7 @@
           <a:p>
             <a:fld id="{755DF60E-8B57-924B-825F-23BE3BB50F9C}" type="datetimeFigureOut">
               <a:rPr lang="en-US" smtClean="0"/>
-              <a:t>7/28/26</a:t>
+              <a:t>8/1/26</a:t>
             </a:fld>
             <a:endParaRPr lang="en-US"/>
           </a:p>
@@ -20274,7 +20387,7 @@
           <a:p>
             <a:fld id="{755DF60E-8B57-924B-825F-23BE3BB50F9C}" type="datetimeFigureOut">
               <a:rPr lang="en-US" smtClean="0"/>
-              <a:t>7/28/26</a:t>
+              <a:t>8/1/26</a:t>
             </a:fld>
             <a:endParaRPr lang="en-US"/>
           </a:p>
@@ -20675,7 +20788,7 @@
           <a:p>
             <a:fld id="{755DF60E-8B57-924B-825F-23BE3BB50F9C}" type="datetimeFigureOut">
               <a:rPr lang="en-US" smtClean="0"/>
-              <a:t>7/28/26</a:t>
+              <a:t>8/1/26</a:t>
             </a:fld>
             <a:endParaRPr lang="en-US"/>
           </a:p>
@@ -21011,7 +21124,7 @@
           <a:p>
             <a:fld id="{755DF60E-8B57-924B-825F-23BE3BB50F9C}" type="datetimeFigureOut">
               <a:rPr lang="en-US" smtClean="0"/>
-              <a:t>7/28/26</a:t>
+              <a:t>8/1/26</a:t>
             </a:fld>
             <a:endParaRPr lang="en-US"/>
           </a:p>
@@ -21331,7 +21444,7 @@
           <a:p>
             <a:fld id="{755DF60E-8B57-924B-825F-23BE3BB50F9C}" type="datetimeFigureOut">
               <a:rPr lang="en-US" smtClean="0"/>
-              <a:t>7/28/26</a:t>
+              <a:t>8/1/26</a:t>
             </a:fld>
             <a:endParaRPr lang="en-US"/>
           </a:p>
@@ -21727,7 +21840,7 @@
           <a:p>
             <a:fld id="{755DF60E-8B57-924B-825F-23BE3BB50F9C}" type="datetimeFigureOut">
               <a:rPr lang="en-US" smtClean="0"/>
-              <a:t>7/28/26</a:t>
+              <a:t>8/1/26</a:t>
             </a:fld>
             <a:endParaRPr lang="en-US"/>
           </a:p>
@@ -21984,7 +22097,7 @@
           <a:p>
             <a:fld id="{755DF60E-8B57-924B-825F-23BE3BB50F9C}" type="datetimeFigureOut">
               <a:rPr lang="en-US" smtClean="0"/>
-              <a:t>7/28/26</a:t>
+              <a:t>8/1/26</a:t>
             </a:fld>
             <a:endParaRPr lang="en-US"/>
           </a:p>
@@ -22246,7 +22359,7 @@
           <a:p>
             <a:fld id="{755DF60E-8B57-924B-825F-23BE3BB50F9C}" type="datetimeFigureOut">
               <a:rPr lang="en-US" smtClean="0"/>
-              <a:t>7/28/26</a:t>
+              <a:t>8/1/26</a:t>
             </a:fld>
             <a:endParaRPr lang="en-US"/>
           </a:p>
@@ -22508,7 +22621,7 @@
           <a:p>
             <a:fld id="{755DF60E-8B57-924B-825F-23BE3BB50F9C}" type="datetimeFigureOut">
               <a:rPr lang="en-US" smtClean="0"/>
-              <a:t>7/28/26</a:t>
+              <a:t>8/1/26</a:t>
             </a:fld>
             <a:endParaRPr lang="en-US"/>
           </a:p>
@@ -22614,6 +22727,13 @@
             <a:noFill/>
           </a:ln>
         </p:spPr>
+        <p:txBody>
+          <a:bodyPr/>
+          <a:lstStyle/>
+          <a:p>
+            <a:endParaRPr lang="en-US"/>
+          </a:p>
+        </p:txBody>
       </p:sp>
       <p:sp>
         <p:nvSpPr>
@@ -22837,7 +22957,7 @@
           <a:p>
             <a:fld id="{755DF60E-8B57-924B-825F-23BE3BB50F9C}" type="datetimeFigureOut">
               <a:rPr lang="en-US" smtClean="0"/>
-              <a:t>7/28/26</a:t>
+              <a:t>8/1/26</a:t>
             </a:fld>
             <a:endParaRPr lang="en-US"/>
           </a:p>
@@ -23160,7 +23280,7 @@
           <a:p>
             <a:fld id="{755DF60E-8B57-924B-825F-23BE3BB50F9C}" type="datetimeFigureOut">
               <a:rPr lang="en-US" smtClean="0"/>
-              <a:t>7/28/26</a:t>
+              <a:t>8/1/26</a:t>
             </a:fld>
             <a:endParaRPr lang="en-US"/>
           </a:p>
@@ -23624,7 +23744,7 @@
           <a:p>
             <a:fld id="{755DF60E-8B57-924B-825F-23BE3BB50F9C}" type="datetimeFigureOut">
               <a:rPr lang="en-US" smtClean="0"/>
-              <a:t>7/28/26</a:t>
+              <a:t>8/1/26</a:t>
             </a:fld>
             <a:endParaRPr lang="en-US"/>
           </a:p>
@@ -23829,7 +23949,7 @@
           <a:p>
             <a:fld id="{755DF60E-8B57-924B-825F-23BE3BB50F9C}" type="datetimeFigureOut">
               <a:rPr lang="en-US" smtClean="0"/>
-              <a:t>7/28/26</a:t>
+              <a:t>8/1/26</a:t>
             </a:fld>
             <a:endParaRPr lang="en-US"/>
           </a:p>
@@ -24006,7 +24126,7 @@
           <a:p>
             <a:fld id="{755DF60E-8B57-924B-825F-23BE3BB50F9C}" type="datetimeFigureOut">
               <a:rPr lang="en-US" smtClean="0"/>
-              <a:t>7/28/26</a:t>
+              <a:t>8/1/26</a:t>
             </a:fld>
             <a:endParaRPr lang="en-US"/>
           </a:p>
@@ -24339,7 +24459,7 @@
           <a:p>
             <a:fld id="{755DF60E-8B57-924B-825F-23BE3BB50F9C}" type="datetimeFigureOut">
               <a:rPr lang="en-US" smtClean="0"/>
-              <a:t>7/28/26</a:t>
+              <a:t>8/1/26</a:t>
             </a:fld>
             <a:endParaRPr lang="en-US"/>
           </a:p>
@@ -24684,7 +24804,7 @@
           <a:p>
             <a:fld id="{755DF60E-8B57-924B-825F-23BE3BB50F9C}" type="datetimeFigureOut">
               <a:rPr lang="en-US" smtClean="0"/>
-              <a:t>7/28/26</a:t>
+              <a:t>8/1/26</a:t>
             </a:fld>
             <a:endParaRPr lang="en-US"/>
           </a:p>
@@ -26976,7 +27096,7 @@
           <a:p>
             <a:fld id="{755DF60E-8B57-924B-825F-23BE3BB50F9C}" type="datetimeFigureOut">
               <a:rPr lang="en-US" smtClean="0"/>
-              <a:t>7/28/26</a:t>
+              <a:t>8/1/26</a:t>
             </a:fld>
             <a:endParaRPr lang="en-US"/>
           </a:p>
@@ -27667,7 +27787,7 @@
         </p:nvSpPr>
         <p:spPr>
           <a:xfrm>
-            <a:off x="2032000" y="1264555"/>
+            <a:off x="687389" y="1264555"/>
             <a:ext cx="4313864" cy="2941983"/>
           </a:xfrm>
         </p:spPr>
@@ -27733,7 +27853,7 @@
         </p:nvSpPr>
         <p:spPr>
           <a:xfrm>
-            <a:off x="6634155" y="1264555"/>
+            <a:off x="5001253" y="1264555"/>
             <a:ext cx="4313864" cy="2941983"/>
           </a:xfrm>
         </p:spPr>
@@ -27811,6 +27931,77 @@
           </a:graphicData>
         </a:graphic>
       </p:graphicFrame>
+      <p:sp>
+        <p:nvSpPr>
+          <p:cNvPr id="6" name="TextBox 5">
+            <a:extLst>
+              <a:ext uri="{FF2B5EF4-FFF2-40B4-BE49-F238E27FC236}">
+                <a16:creationId xmlns:a16="http://schemas.microsoft.com/office/drawing/2014/main" id="{B3265A0B-FEE8-B94F-D4E5-7CDB807FDF51}"/>
+              </a:ext>
+            </a:extLst>
+          </p:cNvPr>
+          <p:cNvSpPr txBox="1"/>
+          <p:nvPr/>
+        </p:nvSpPr>
+        <p:spPr>
+          <a:xfrm>
+            <a:off x="9315117" y="1264554"/>
+            <a:ext cx="2189494" cy="2954655"/>
+          </a:xfrm>
+          <a:prstGeom prst="rect">
+            <a:avLst/>
+          </a:prstGeom>
+          <a:noFill/>
+        </p:spPr>
+        <p:txBody>
+          <a:bodyPr wrap="square" rtlCol="0">
+            <a:spAutoFit/>
+          </a:bodyPr>
+          <a:lstStyle/>
+          <a:p>
+            <a:r>
+              <a:rPr lang="en-US" b="1" dirty="0">
+                <a:solidFill>
+                  <a:schemeClr val="tx1">
+                    <a:lumMod val="75000"/>
+                    <a:lumOff val="25000"/>
+                  </a:schemeClr>
+                </a:solidFill>
+              </a:rPr>
+              <a:t>Example Review</a:t>
+            </a:r>
+          </a:p>
+          <a:p>
+            <a:r>
+              <a:rPr lang="en-US" sz="1400" i="1" dirty="0"/>
+              <a:t>"The suspension feels plush through rock gardens but becomes harsh on repeated square-edge hits, while the rear end remains composed under braking."</a:t>
+            </a:r>
+            <a:endParaRPr lang="en-US" sz="1400" dirty="0"/>
+          </a:p>
+          <a:p>
+            <a:endParaRPr lang="en-US" sz="1400" dirty="0"/>
+          </a:p>
+          <a:p>
+            <a:r>
+              <a:rPr lang="en-US" sz="1400" b="1" dirty="0">
+                <a:solidFill>
+                  <a:schemeClr val="tx1">
+                    <a:lumMod val="75000"/>
+                    <a:lumOff val="25000"/>
+                  </a:schemeClr>
+                </a:solidFill>
+              </a:rPr>
+              <a:t>Domain-specific terms:</a:t>
+            </a:r>
+          </a:p>
+          <a:p>
+            <a:r>
+              <a:rPr lang="en-US" sz="1400" dirty="0"/>
+              <a:t>plush, harsh, square-edge, composed</a:t>
+            </a:r>
+          </a:p>
+        </p:txBody>
+      </p:sp>
     </p:spTree>
     <p:extLst>
       <p:ext uri="{BB962C8B-B14F-4D97-AF65-F5344CB8AC3E}">
@@ -28763,7 +28954,7 @@
             <a:pPr lvl="0"/>
             <a:r>
               <a:rPr lang="en-US" sz="1600" dirty="0"/>
-              <a:t>Domain-specific supervised learning outperformed more complex pretrained models in this specialized review domain. </a:t>
+              <a:t>Domain-specific vocabulary allowed the supervised model to outperform the more complex pretrained transformer.</a:t>
             </a:r>
           </a:p>
         </p:txBody>
@@ -29105,7 +29296,7 @@
             <p:ph idx="1"/>
             <p:extLst>
               <p:ext uri="{D42A27DB-BD31-4B8C-83A1-F6EECF244321}">
-                <p14:modId xmlns:p14="http://schemas.microsoft.com/office/powerpoint/2010/main" val="3456829644"/>
+                <p14:modId xmlns:p14="http://schemas.microsoft.com/office/powerpoint/2010/main" val="3516641702"/>
               </p:ext>
             </p:extLst>
           </p:nvPr>
@@ -29194,13 +29385,13 @@
             <p:ph idx="1"/>
             <p:extLst>
               <p:ext uri="{D42A27DB-BD31-4B8C-83A1-F6EECF244321}">
-                <p14:modId xmlns:p14="http://schemas.microsoft.com/office/powerpoint/2010/main" val="533329665"/>
+                <p14:modId xmlns:p14="http://schemas.microsoft.com/office/powerpoint/2010/main" val="2591578330"/>
               </p:ext>
             </p:extLst>
           </p:nvPr>
         </p:nvGraphicFramePr>
         <p:xfrm>
-          <a:off x="2589212" y="1264555"/>
+          <a:off x="1638300" y="1264555"/>
           <a:ext cx="8915400" cy="3778250"/>
         </p:xfrm>
         <a:graphic>
@@ -29223,7 +29414,7 @@
         </p:nvSpPr>
         <p:spPr>
           <a:xfrm>
-            <a:off x="2589212" y="5181600"/>
+            <a:off x="1638300" y="5270279"/>
             <a:ext cx="8915400" cy="646331"/>
           </a:xfrm>
           <a:prstGeom prst="rect">

</xml_diff>